<commit_message>
lesson: teach contextual financial chunking
</commit_message>
<xml_diff>
--- a/decks/05-document-and-chunking-lab.pptx
+++ b/decks/05-document-and-chunking-lab.pptx
@@ -2,20 +2,20 @@
 <file path=ppt/presentation.xml><?xml version="1.0" encoding="utf-8"?>
 <p:presentation xmlns:p="http://schemas.openxmlformats.org/presentationml/2006/main">
   <p:sldMasterIdLst>
-    <p:sldMasterId xmlns:r="http://schemas.openxmlformats.org/officeDocument/2006/relationships" id="2147483648" r:id="R45edbdd840124414"/>
+    <p:sldMasterId xmlns:r="http://schemas.openxmlformats.org/officeDocument/2006/relationships" id="2147483648" r:id="Rcc0839dc76bd4699"/>
   </p:sldMasterIdLst>
   <p:notesMasterIdLst>
-    <p:notesMasterId xmlns:r="http://schemas.openxmlformats.org/officeDocument/2006/relationships" r:id="R98038520255f4d89"/>
+    <p:notesMasterId xmlns:r="http://schemas.openxmlformats.org/officeDocument/2006/relationships" r:id="R016fcb1d279e4465"/>
   </p:notesMasterIdLst>
   <p:sldIdLst>
-    <p:sldId xmlns:r="http://schemas.openxmlformats.org/officeDocument/2006/relationships" id="256" r:id="R0353ba52e27c44ec"/>
-    <p:sldId xmlns:r="http://schemas.openxmlformats.org/officeDocument/2006/relationships" id="257" r:id="R53748089cf1441e0"/>
-    <p:sldId xmlns:r="http://schemas.openxmlformats.org/officeDocument/2006/relationships" id="258" r:id="Rcd8ecda44af74713"/>
-    <p:sldId xmlns:r="http://schemas.openxmlformats.org/officeDocument/2006/relationships" id="259" r:id="R002671e268a74e6f"/>
-    <p:sldId xmlns:r="http://schemas.openxmlformats.org/officeDocument/2006/relationships" id="260" r:id="Rca1820ad07714e41"/>
-    <p:sldId xmlns:r="http://schemas.openxmlformats.org/officeDocument/2006/relationships" id="261" r:id="R92461eba96d44f0e"/>
-    <p:sldId xmlns:r="http://schemas.openxmlformats.org/officeDocument/2006/relationships" id="262" r:id="R9da03e5aa3d545ed"/>
-    <p:sldId xmlns:r="http://schemas.openxmlformats.org/officeDocument/2006/relationships" id="263" r:id="R10e9ffe7040147b7"/>
+    <p:sldId xmlns:r="http://schemas.openxmlformats.org/officeDocument/2006/relationships" id="256" r:id="R28b58dbd83c6442a"/>
+    <p:sldId xmlns:r="http://schemas.openxmlformats.org/officeDocument/2006/relationships" id="257" r:id="R4ea80f206c094faf"/>
+    <p:sldId xmlns:r="http://schemas.openxmlformats.org/officeDocument/2006/relationships" id="258" r:id="Re24f841d7e6d42ff"/>
+    <p:sldId xmlns:r="http://schemas.openxmlformats.org/officeDocument/2006/relationships" id="259" r:id="Re8be3596dfc84d43"/>
+    <p:sldId xmlns:r="http://schemas.openxmlformats.org/officeDocument/2006/relationships" id="260" r:id="R7e814073f17d4fad"/>
+    <p:sldId xmlns:r="http://schemas.openxmlformats.org/officeDocument/2006/relationships" id="261" r:id="R4b391109446d4bfc"/>
+    <p:sldId xmlns:r="http://schemas.openxmlformats.org/officeDocument/2006/relationships" id="262" r:id="R1e25e06be2a0499e"/>
+    <p:sldId xmlns:r="http://schemas.openxmlformats.org/officeDocument/2006/relationships" id="263" r:id="Rfdeb9179498b4fde"/>
   </p:sldIdLst>
   <p:sldSz cx="15240000" cy="8572500"/>
   <p:notesSz cx="6858000" cy="9144000"/>
@@ -644,12 +644,7 @@
           <a:lstStyle xmlns:a="http://schemas.openxmlformats.org/drawingml/2006/main"/>
           <a:p xmlns:a="http://schemas.openxmlformats.org/drawingml/2006/main">
             <a:r>
-              <a:t>Separate the parser contract from the chunking policy.</a:t>
-            </a:r>
-          </a:p>
-          <a:p xmlns:a="http://schemas.openxmlformats.org/drawingml/2006/main">
-            <a:r>
-              <a:t>The canonical block model is the stable boundary between them.</a:t>
+              <a:t>Use the five stages as a parser-quality ladder: source bytes, text extraction, layout recovery, canonical blocks, then a quality gate. Chunking starts only after the evidence unit is trustworthy.</a:t>
             </a:r>
           </a:p>
           <a:p xmlns:a="http://schemas.openxmlformats.org/drawingml/2006/main">
@@ -939,17 +934,7 @@
           <a:lstStyle xmlns:a="http://schemas.openxmlformats.org/drawingml/2006/main"/>
           <a:p xmlns:a="http://schemas.openxmlformats.org/drawingml/2006/main">
             <a:r>
-              <a:t>Semantic chunking requires both a representation and a boundary threshold.</a:t>
-            </a:r>
-          </a:p>
-          <a:p xmlns:a="http://schemas.openxmlformats.org/drawingml/2006/main">
-            <a:r>
-              <a:t>Hierarchical chunking separates matching granularity from reading context.</a:t>
-            </a:r>
-          </a:p>
-          <a:p xmlns:a="http://schemas.openxmlformats.org/drawingml/2006/main">
-            <a:r>
-              <a:t>Contextual prefixes and LLM propositions add cost and must be evaluated against original evidence.</a:t>
+              <a:t>Separate three decisions. Embedding model plus threshold creates semantic boundaries. Parent-child links separate matching from reading. Contextual enrichment is one bounded JSON transformation, not agentic chunking; generated context augments immutable raw_text. The 1.37x token ratio is the deterministic Notebook 05 offline measurement.</a:t>
             </a:r>
           </a:p>
           <a:p xmlns:a="http://schemas.openxmlformats.org/drawingml/2006/main">
@@ -964,7 +949,17 @@
           </a:p>
           <a:p xmlns:a="http://schemas.openxmlformats.org/drawingml/2006/main">
             <a:r>
-              <a:t>- https://scikit-learn.org/stable/modules/generated/sklearn.feature_extraction.text.TfidfVectorizer.html</a:t>
+              <a:t>- https://platform.openai.com/docs/guides/embeddings</a:t>
+            </a:r>
+          </a:p>
+          <a:p xmlns:a="http://schemas.openxmlformats.org/drawingml/2006/main">
+            <a:r>
+              <a:t>- https://docs.ollama.com/capabilities/embeddings</a:t>
+            </a:r>
+          </a:p>
+          <a:p xmlns:a="http://schemas.openxmlformats.org/drawingml/2006/main">
+            <a:r>
+              <a:t>- Course Notebook 05 offline execution, contextual-chunks-v1</a:t>
             </a:r>
           </a:p>
           <a:p xmlns:a="http://schemas.openxmlformats.org/drawingml/2006/main">
@@ -1139,17 +1134,7 @@
           <a:lstStyle xmlns:a="http://schemas.openxmlformats.org/drawingml/2006/main"/>
           <a:p xmlns:a="http://schemas.openxmlformats.org/drawingml/2006/main">
             <a:r>
-              <a:t>Recommend a structure-aware child representation as the initial policy, not a universal final answer.</a:t>
-            </a:r>
-          </a:p>
-          <a:p xmlns:a="http://schemas.openxmlformats.org/drawingml/2006/main">
-            <a:r>
-              <a:t>Parent links restore context after retrieval while keeping the index granular.</a:t>
-            </a:r>
-          </a:p>
-          <a:p xmlns:a="http://schemas.openxmlformats.org/drawingml/2006/main">
-            <a:r>
-              <a:t>Lesson 06 holds these chunks constant and improves representation and ranking.</a:t>
+              <a:t>Use structure-aware chunks as the filing baseline. Add semantic boundaries or hierarchy when matching is weak; add LLM contextual enrichment only when passages remain ambiguous and measured retrieval improves enough to justify tokens, latency and transformation risk.</a:t>
             </a:r>
           </a:p>
           <a:p xmlns:a="http://schemas.openxmlformats.org/drawingml/2006/main">
@@ -1164,7 +1149,12 @@
           </a:p>
           <a:p xmlns:a="http://schemas.openxmlformats.org/drawingml/2006/main">
             <a:r>
-              <a:t>- Course-owned diagram and copy.</a:t>
+              <a:t>- Course-owned decision matrix</a:t>
+            </a:r>
+          </a:p>
+          <a:p xmlns:a="http://schemas.openxmlformats.org/drawingml/2006/main">
+            <a:r>
+              <a:t>- Course Notebook 05 offline execution</a:t>
             </a:r>
           </a:p>
           <a:p xmlns:a="http://schemas.openxmlformats.org/drawingml/2006/main">
@@ -1237,7 +1227,7 @@
   </p:cSld>
   <p:clrMap bg1="lt1" tx1="dk1" bg2="lt2" tx2="dk2" accent1="accent1" accent2="accent2" accent3="accent3" accent4="accent4" accent5="accent5" accent6="accent6" hlink="hlink" folHlink="folHlink"/>
   <p:sldLayoutIdLst>
-    <p:sldLayoutId xmlns:r="http://schemas.openxmlformats.org/officeDocument/2006/relationships" id="2147483649" r:id="R3afdb4cdc0394479"/>
+    <p:sldLayoutId xmlns:r="http://schemas.openxmlformats.org/officeDocument/2006/relationships" id="2147483649" r:id="R2c879c68dfea4606"/>
   </p:sldLayoutIdLst>
   <p:txStyles>
     <p:titleStyle>
@@ -3984,7 +3974,7 @@
       </p:sp>
       <p:cxnSp>
         <p:nvCxnSpPr>
-          <p:cNvPr id="80" name=""/>
+          <p:cNvPr id="154" name=""/>
           <p:cNvCxnSpPr>
             <a:stCxn xmlns:a="http://schemas.openxmlformats.org/drawingml/2006/main" id="4" idx="3"/>
             <a:endCxn xmlns:a="http://schemas.openxmlformats.org/drawingml/2006/main" id="30" idx="1"/>
@@ -4408,7 +4398,7 @@
                 <a:ea typeface="Calibri"/>
                 <a:cs typeface="Calibri"/>
               </a:rPr>
-              <a:t>INGESTION BOUNDARY</a:t>
+              <a:t>PARSER LADDER</a:t>
             </a:r>
           </a:p>
         </p:txBody>
@@ -4470,7 +4460,7 @@
                 <a:ea typeface="Calibri"/>
                 <a:cs typeface="Calibri"/>
               </a:rPr>
-              <a:t>Normalize format-specific inputs before choosing chunks</a:t>
+              <a:t>Verify extraction quality before choosing chunk boundaries</a:t>
             </a:r>
           </a:p>
         </p:txBody>
@@ -4629,7 +4619,7 @@
                 <a:ea typeface="Calibri"/>
                 <a:cs typeface="Calibri"/>
               </a:rPr>
-              <a:t>Official source</a:t>
+              <a:t>Raw source</a:t>
             </a:r>
           </a:p>
         </p:txBody>
@@ -4691,7 +4681,7 @@
                 <a:ea typeface="Calibri"/>
                 <a:cs typeface="Calibri"/>
               </a:rPr>
-              <a:t>SEC HTML or PDF</a:t>
+              <a:t>HTML · PDF</a:t>
             </a:r>
           </a:p>
         </p:txBody>
@@ -4850,7 +4840,7 @@
                 <a:ea typeface="Calibri"/>
                 <a:cs typeface="Calibri"/>
               </a:rPr>
-              <a:t>Parser</a:t>
+              <a:t>Text extraction</a:t>
             </a:r>
           </a:p>
         </p:txBody>
@@ -4912,7 +4902,7 @@
                 <a:ea typeface="Calibri"/>
                 <a:cs typeface="Calibri"/>
               </a:rPr>
-              <a:t>elements · pages · tables</a:t>
+              <a:t>characters · words · lines</a:t>
             </a:r>
           </a:p>
         </p:txBody>
@@ -5071,7 +5061,7 @@
                 <a:ea typeface="Calibri"/>
                 <a:cs typeface="Calibri"/>
               </a:rPr>
-              <a:t>DocumentBlock</a:t>
+              <a:t>Layout recovery</a:t>
             </a:r>
           </a:p>
         </p:txBody>
@@ -5133,7 +5123,7 @@
                 <a:ea typeface="Calibri"/>
                 <a:cs typeface="Calibri"/>
               </a:rPr>
-              <a:t>order · structure · source</a:t>
+              <a:t>tables · headings · order</a:t>
             </a:r>
           </a:p>
         </p:txBody>
@@ -5292,7 +5282,7 @@
                 <a:ea typeface="Calibri"/>
                 <a:cs typeface="Calibri"/>
               </a:rPr>
-              <a:t>Quality checks</a:t>
+              <a:t>DocumentBlock</a:t>
             </a:r>
           </a:p>
         </p:txBody>
@@ -5354,7 +5344,7 @@
                 <a:ea typeface="Calibri"/>
                 <a:cs typeface="Calibri"/>
               </a:rPr>
-              <a:t>tables · headings · provenance</a:t>
+              <a:t>text · structure · provenance</a:t>
             </a:r>
           </a:p>
         </p:txBody>
@@ -5513,7 +5503,7 @@
                 <a:ea typeface="Calibri"/>
                 <a:cs typeface="Calibri"/>
               </a:rPr>
-              <a:t>Chunk strategy</a:t>
+              <a:t>Quality gate</a:t>
             </a:r>
           </a:p>
         </p:txBody>
@@ -5575,14 +5565,14 @@
                 <a:ea typeface="Calibri"/>
                 <a:cs typeface="Calibri"/>
               </a:rPr>
-              <a:t>controlled evidence units</a:t>
+              <a:t>visual checks · integrity</a:t>
             </a:r>
           </a:p>
         </p:txBody>
       </p:sp>
       <p:cxnSp>
         <p:nvCxnSpPr>
-          <p:cNvPr id="57" name=""/>
+          <p:cNvPr id="109" name=""/>
           <p:cNvCxnSpPr>
             <a:stCxn xmlns:a="http://schemas.openxmlformats.org/drawingml/2006/main" id="3" idx="3"/>
             <a:endCxn xmlns:a="http://schemas.openxmlformats.org/drawingml/2006/main" id="7" idx="1"/>
@@ -5608,7 +5598,7 @@
       </p:cxnSp>
       <p:cxnSp>
         <p:nvCxnSpPr>
-          <p:cNvPr id="58" name=""/>
+          <p:cNvPr id="110" name=""/>
           <p:cNvCxnSpPr>
             <a:stCxn xmlns:a="http://schemas.openxmlformats.org/drawingml/2006/main" id="7" idx="3"/>
             <a:endCxn xmlns:a="http://schemas.openxmlformats.org/drawingml/2006/main" id="11" idx="1"/>
@@ -5634,7 +5624,7 @@
       </p:cxnSp>
       <p:cxnSp>
         <p:nvCxnSpPr>
-          <p:cNvPr id="59" name=""/>
+          <p:cNvPr id="111" name=""/>
           <p:cNvCxnSpPr>
             <a:stCxn xmlns:a="http://schemas.openxmlformats.org/drawingml/2006/main" id="11" idx="3"/>
             <a:endCxn xmlns:a="http://schemas.openxmlformats.org/drawingml/2006/main" id="15" idx="1"/>
@@ -5660,7 +5650,7 @@
       </p:cxnSp>
       <p:cxnSp>
         <p:nvCxnSpPr>
-          <p:cNvPr id="60" name=""/>
+          <p:cNvPr id="112" name=""/>
           <p:cNvCxnSpPr>
             <a:stCxn xmlns:a="http://schemas.openxmlformats.org/drawingml/2006/main" id="15" idx="3"/>
             <a:endCxn xmlns:a="http://schemas.openxmlformats.org/drawingml/2006/main" id="19" idx="1"/>
@@ -5741,7 +5731,7 @@
                 <a:ea typeface="Calibri"/>
                 <a:cs typeface="Calibri"/>
               </a:rPr>
-              <a:t>One canonical block model lets parsing and chunking evolve independently.</a:t>
+              <a:t>Chunking begins only after extraction, layout and provenance pass.</a:t>
             </a:r>
           </a:p>
         </p:txBody>
@@ -5803,7 +5793,7 @@
                 <a:ea typeface="Calibri"/>
                 <a:cs typeface="Calibri"/>
               </a:rPr>
-              <a:t>Parser describes the document</a:t>
+              <a:t>Extraction recovers document signals</a:t>
             </a:r>
           </a:p>
         </p:txBody>
@@ -5865,7 +5855,7 @@
                 <a:ea typeface="Calibri"/>
                 <a:cs typeface="Calibri"/>
               </a:rPr>
-              <a:t>Chunker chooses retrievable evidence units</a:t>
+              <a:t>Quality gate protects evidence units</a:t>
             </a:r>
           </a:p>
         </p:txBody>
@@ -7512,7 +7502,7 @@
       </p:sp>
       <p:cxnSp>
         <p:nvCxnSpPr>
-          <p:cNvPr id="63" name=""/>
+          <p:cNvPr id="125" name=""/>
           <p:cNvCxnSpPr>
             <a:stCxn xmlns:a="http://schemas.openxmlformats.org/drawingml/2006/main" id="8" idx="3"/>
             <a:endCxn xmlns:a="http://schemas.openxmlformats.org/drawingml/2006/main" id="3" idx="1"/>
@@ -7538,7 +7528,7 @@
       </p:cxnSp>
       <p:cxnSp>
         <p:nvCxnSpPr>
-          <p:cNvPr id="64" name=""/>
+          <p:cNvPr id="126" name=""/>
           <p:cNvCxnSpPr>
             <a:stCxn xmlns:a="http://schemas.openxmlformats.org/drawingml/2006/main" id="11" idx="3"/>
             <a:endCxn xmlns:a="http://schemas.openxmlformats.org/drawingml/2006/main" id="3" idx="1"/>
@@ -7564,7 +7554,7 @@
       </p:cxnSp>
       <p:cxnSp>
         <p:nvCxnSpPr>
-          <p:cNvPr id="65" name=""/>
+          <p:cNvPr id="127" name=""/>
           <p:cNvCxnSpPr>
             <a:stCxn xmlns:a="http://schemas.openxmlformats.org/drawingml/2006/main" id="14" idx="3"/>
             <a:endCxn xmlns:a="http://schemas.openxmlformats.org/drawingml/2006/main" id="3" idx="1"/>
@@ -7590,7 +7580,7 @@
       </p:cxnSp>
       <p:cxnSp>
         <p:nvCxnSpPr>
-          <p:cNvPr id="66" name=""/>
+          <p:cNvPr id="128" name=""/>
           <p:cNvCxnSpPr>
             <a:stCxn xmlns:a="http://schemas.openxmlformats.org/drawingml/2006/main" id="3" idx="3"/>
             <a:endCxn xmlns:a="http://schemas.openxmlformats.org/drawingml/2006/main" id="17" idx="1"/>
@@ -7616,7 +7606,7 @@
       </p:cxnSp>
       <p:cxnSp>
         <p:nvCxnSpPr>
-          <p:cNvPr id="67" name=""/>
+          <p:cNvPr id="129" name=""/>
           <p:cNvCxnSpPr>
             <a:stCxn xmlns:a="http://schemas.openxmlformats.org/drawingml/2006/main" id="3" idx="3"/>
             <a:endCxn xmlns:a="http://schemas.openxmlformats.org/drawingml/2006/main" id="20" idx="1"/>
@@ -7642,7 +7632,7 @@
       </p:cxnSp>
       <p:cxnSp>
         <p:nvCxnSpPr>
-          <p:cNvPr id="68" name=""/>
+          <p:cNvPr id="130" name=""/>
           <p:cNvCxnSpPr>
             <a:stCxn xmlns:a="http://schemas.openxmlformats.org/drawingml/2006/main" id="3" idx="3"/>
             <a:endCxn xmlns:a="http://schemas.openxmlformats.org/drawingml/2006/main" id="23" idx="1"/>
@@ -9846,7 +9836,7 @@
                 <a:ea typeface="Calibri"/>
                 <a:cs typeface="Calibri"/>
               </a:rPr>
-              <a:t>ADVANCED PATTERNS</a:t>
+              <a:t>SEMANTIC + CONTEXTUAL</a:t>
             </a:r>
           </a:p>
         </p:txBody>
@@ -9881,7 +9871,7 @@
         </p:spPr>
         <p:txBody>
           <a:bodyPr xmlns:a="http://schemas.openxmlformats.org/drawingml/2006/main" wrap="none" lIns="0" tIns="0" rIns="0" bIns="0" anchor="ctr">
-            <a:normAutofit fontScale="83164"/>
+            <a:normAutofit fontScale="88682"/>
           </a:bodyPr>
           <a:lstStyle xmlns:a="http://schemas.openxmlformats.org/drawingml/2006/main"/>
           <a:p xmlns:a="http://schemas.openxmlformats.org/drawingml/2006/main">
@@ -9908,7 +9898,7 @@
                 <a:ea typeface="Calibri"/>
                 <a:cs typeface="Calibri"/>
               </a:rPr>
-              <a:t>Semantic, hierarchical and LLM-assisted chunks solve different problems</a:t>
+              <a:t>Embedding boundaries, hierarchy and context solve different failures</a:t>
             </a:r>
           </a:p>
         </p:txBody>
@@ -9970,7 +9960,7 @@
                 <a:ea typeface="Calibri"/>
                 <a:cs typeface="Calibri"/>
               </a:rPr>
-              <a:t>SEMANTIC BOUNDARY</a:t>
+              <a:t>EMBEDDING BOUNDARY</a:t>
             </a:r>
           </a:p>
         </p:txBody>
@@ -10296,7 +10286,7 @@
                 <a:ea typeface="Calibri"/>
                 <a:cs typeface="Calibri"/>
               </a:rPr>
-              <a:t>low similarity → boundary</a:t>
+              <a:t>model + threshold → boundary</a:t>
             </a:r>
           </a:p>
         </p:txBody>
@@ -10753,7 +10743,7 @@
       </p:sp>
       <p:cxnSp>
         <p:nvCxnSpPr>
-          <p:cNvPr id="62" name=""/>
+          <p:cNvPr id="110" name=""/>
           <p:cNvCxnSpPr>
             <a:stCxn xmlns:a="http://schemas.openxmlformats.org/drawingml/2006/main" id="14" idx="2"/>
             <a:endCxn xmlns:a="http://schemas.openxmlformats.org/drawingml/2006/main" id="16" idx="0"/>
@@ -10779,7 +10769,7 @@
       </p:cxnSp>
       <p:cxnSp>
         <p:nvCxnSpPr>
-          <p:cNvPr id="63" name=""/>
+          <p:cNvPr id="111" name=""/>
           <p:cNvCxnSpPr>
             <a:stCxn xmlns:a="http://schemas.openxmlformats.org/drawingml/2006/main" id="14" idx="2"/>
             <a:endCxn xmlns:a="http://schemas.openxmlformats.org/drawingml/2006/main" id="18" idx="0"/>
@@ -10805,7 +10795,7 @@
       </p:cxnSp>
       <p:cxnSp>
         <p:nvCxnSpPr>
-          <p:cNvPr id="64" name=""/>
+          <p:cNvPr id="112" name=""/>
           <p:cNvCxnSpPr>
             <a:stCxn xmlns:a="http://schemas.openxmlformats.org/drawingml/2006/main" id="14" idx="2"/>
             <a:endCxn xmlns:a="http://schemas.openxmlformats.org/drawingml/2006/main" id="20" idx="0"/>
@@ -10948,7 +10938,7 @@
                 <a:ea typeface="Calibri"/>
                 <a:cs typeface="Calibri"/>
               </a:rPr>
-              <a:t>CONTEXT + PROPOSITIONS</a:t>
+              <a:t>RAW + GENERATED CONTEXT</a:t>
             </a:r>
           </a:p>
         </p:txBody>
@@ -11045,7 +11035,7 @@
                 <a:ea typeface="Calibri"/>
                 <a:cs typeface="Calibri"/>
               </a:rPr>
-              <a:t>NVIDIA | FY2026 | Data Center</a:t>
+              <a:t>RAW EVIDENCE</a:t>
             </a:r>
           </a:p>
         </p:txBody>
@@ -11107,7 +11097,7 @@
                 <a:ea typeface="Calibri"/>
                 <a:cs typeface="Calibri"/>
               </a:rPr>
-              <a:t>+ original evidence chunk</a:t>
+              <a:t>NVIDIA FY2026 · stable source text</a:t>
             </a:r>
           </a:p>
         </p:txBody>
@@ -11204,7 +11194,7 @@
                 <a:ea typeface="Calibri"/>
                 <a:cs typeface="Calibri"/>
               </a:rPr>
-              <a:t>ATOMIC CLAIM</a:t>
+              <a:t>GENERATED CONTEXT</a:t>
             </a:r>
           </a:p>
         </p:txBody>
@@ -11266,7 +11256,7 @@
                 <a:ea typeface="Calibri"/>
                 <a:cs typeface="Calibri"/>
               </a:rPr>
-              <a:t>Data Center revenue was</a:t>
+              <a:t>Fiscal 2026 revenue context</a:t>
             </a:r>
           </a:p>
           <a:p xmlns:a="http://schemas.openxmlformats.org/drawingml/2006/main">
@@ -11293,7 +11283,7 @@
                 <a:ea typeface="Calibri"/>
                 <a:cs typeface="Calibri"/>
               </a:rPr>
-              <a:t>USD 193.7bn in FY2026</a:t>
+              <a:t>+ raw evidence at retrieval</a:t>
             </a:r>
           </a:p>
         </p:txBody>
@@ -11328,7 +11318,7 @@
         </p:spPr>
         <p:txBody>
           <a:bodyPr xmlns:a="http://schemas.openxmlformats.org/drawingml/2006/main" wrap="square" lIns="0" tIns="0" rIns="0" bIns="0" anchor="ctr">
-            <a:normAutofit fontScale="97222"/>
+            <a:normAutofit fontScale="100000"/>
           </a:bodyPr>
           <a:lstStyle xmlns:a="http://schemas.openxmlformats.org/drawingml/2006/main"/>
           <a:p xmlns:a="http://schemas.openxmlformats.org/drawingml/2006/main">
@@ -11355,7 +11345,7 @@
                 <a:ea typeface="Calibri"/>
                 <a:cs typeface="Calibri"/>
               </a:rPr>
-              <a:t>extra tokens · model cost · transformation risk</a:t>
+              <a:t>offline: 1.37× tokens · latency · retrieval gain</a:t>
             </a:r>
           </a:p>
         </p:txBody>
@@ -11452,7 +11442,7 @@
                 <a:ea typeface="Calibri"/>
                 <a:cs typeface="Calibri"/>
               </a:rPr>
-              <a:t>No strategy is universally best: version the representation, threshold and evaluation set.</a:t>
+              <a:t>Generated context augments raw_text; preserve IDs, pages and provenance.</a:t>
             </a:r>
           </a:p>
         </p:txBody>
@@ -14160,7 +14150,7 @@
                 <a:ea typeface="Calibri"/>
                 <a:cs typeface="Calibri"/>
               </a:rPr>
-              <a:t>ENGINEERING DECISION</a:t>
+              <a:t>STRATEGY DECISION</a:t>
             </a:r>
           </a:p>
         </p:txBody>
@@ -14195,7 +14185,7 @@
         </p:spPr>
         <p:txBody>
           <a:bodyPr xmlns:a="http://schemas.openxmlformats.org/drawingml/2006/main" wrap="none" lIns="0" tIns="0" rIns="0" bIns="0" anchor="ctr">
-            <a:normAutofit fontScale="100000"/>
+            <a:normAutofit fontScale="98845"/>
           </a:bodyPr>
           <a:lstStyle xmlns:a="http://schemas.openxmlformats.org/drawingml/2006/main"/>
           <a:p xmlns:a="http://schemas.openxmlformats.org/drawingml/2006/main">
@@ -14222,7 +14212,7 @@
                 <a:ea typeface="Calibri"/>
                 <a:cs typeface="Calibri"/>
               </a:rPr>
-              <a:t>Start with structural children and preserve a verified parent</a:t>
+              <a:t>Escalate chunking complexity only when evaluation justifies it</a:t>
             </a:r>
           </a:p>
         </p:txBody>
@@ -14319,7 +14309,7 @@
                 <a:ea typeface="Calibri"/>
                 <a:cs typeface="Calibri"/>
               </a:rPr>
-              <a:t>CANONICAL BLOCKS</a:t>
+              <a:t>STRUCTURE-AWARE</a:t>
             </a:r>
           </a:p>
         </p:txBody>
@@ -14354,7 +14344,7 @@
         </p:spPr>
         <p:txBody>
           <a:bodyPr xmlns:a="http://schemas.openxmlformats.org/drawingml/2006/main" wrap="square" lIns="0" tIns="0" rIns="0" bIns="0" anchor="ctr">
-            <a:normAutofit fontScale="91520"/>
+            <a:normAutofit fontScale="91720"/>
           </a:bodyPr>
           <a:lstStyle xmlns:a="http://schemas.openxmlformats.org/drawingml/2006/main"/>
           <a:p xmlns:a="http://schemas.openxmlformats.org/drawingml/2006/main">
@@ -14381,7 +14371,7 @@
                 <a:ea typeface="Calibri"/>
                 <a:cs typeface="Calibri"/>
               </a:rPr>
-              <a:t>order · page · section</a:t>
+              <a:t>tables + headings intact</a:t>
             </a:r>
           </a:p>
           <a:p xmlns:a="http://schemas.openxmlformats.org/drawingml/2006/main">
@@ -14408,7 +14398,7 @@
                 <a:ea typeface="Calibri"/>
                 <a:cs typeface="Calibri"/>
               </a:rPr>
-              <a:t>table rows · source URL</a:t>
+              <a:t>default for filings</a:t>
             </a:r>
           </a:p>
         </p:txBody>
@@ -14505,7 +14495,7 @@
                 <a:ea typeface="Calibri"/>
                 <a:cs typeface="Calibri"/>
               </a:rPr>
-              <a:t>INDEX</a:t>
+              <a:t>SEMANTIC + HIERARCHICAL</a:t>
             </a:r>
           </a:p>
         </p:txBody>
@@ -14540,7 +14530,7 @@
         </p:spPr>
         <p:txBody>
           <a:bodyPr xmlns:a="http://schemas.openxmlformats.org/drawingml/2006/main" wrap="square" lIns="0" tIns="0" rIns="0" bIns="0" anchor="ctr">
-            <a:normAutofit fontScale="100000"/>
+            <a:normAutofit fontScale="94502"/>
           </a:bodyPr>
           <a:lstStyle xmlns:a="http://schemas.openxmlformats.org/drawingml/2006/main"/>
           <a:p xmlns:a="http://schemas.openxmlformats.org/drawingml/2006/main">
@@ -14567,7 +14557,7 @@
                 <a:ea typeface="Calibri"/>
                 <a:cs typeface="Calibri"/>
               </a:rPr>
-              <a:t>Structure-aware</a:t>
+              <a:t>embedding boundary</a:t>
             </a:r>
           </a:p>
           <a:p xmlns:a="http://schemas.openxmlformats.org/drawingml/2006/main">
@@ -14594,7 +14584,7 @@
                 <a:ea typeface="Calibri"/>
                 <a:cs typeface="Calibri"/>
               </a:rPr>
-              <a:t>child chunks</a:t>
+              <a:t>+ verified parent</a:t>
             </a:r>
           </a:p>
         </p:txBody>
@@ -14656,7 +14646,7 @@
                 <a:ea typeface="Calibri"/>
                 <a:cs typeface="Calibri"/>
               </a:rPr>
-              <a:t>company · period · section</a:t>
+              <a:t>when matching is weak</a:t>
             </a:r>
           </a:p>
         </p:txBody>
@@ -14753,7 +14743,7 @@
                 <a:ea typeface="Calibri"/>
                 <a:cs typeface="Calibri"/>
               </a:rPr>
-              <a:t>AFTER RETRIEVAL</a:t>
+              <a:t>LLM CONTEXTUAL</a:t>
             </a:r>
           </a:p>
         </p:txBody>
@@ -14815,7 +14805,7 @@
                 <a:ea typeface="Calibri"/>
                 <a:cs typeface="Calibri"/>
               </a:rPr>
-              <a:t>Expand the verified</a:t>
+              <a:t>generated context</a:t>
             </a:r>
           </a:p>
           <a:p xmlns:a="http://schemas.openxmlformats.org/drawingml/2006/main">
@@ -14842,14 +14832,14 @@
                 <a:ea typeface="Calibri"/>
                 <a:cs typeface="Calibri"/>
               </a:rPr>
-              <a:t>parent section</a:t>
+              <a:t>+ immutable raw_text</a:t>
             </a:r>
           </a:p>
         </p:txBody>
       </p:sp>
       <p:cxnSp>
         <p:nvCxnSpPr>
-          <p:cNvPr id="40" name=""/>
+          <p:cNvPr id="68" name=""/>
           <p:cNvCxnSpPr>
             <a:stCxn xmlns:a="http://schemas.openxmlformats.org/drawingml/2006/main" id="3" idx="3"/>
             <a:endCxn xmlns:a="http://schemas.openxmlformats.org/drawingml/2006/main" id="6" idx="1"/>
@@ -14875,7 +14865,7 @@
       </p:cxnSp>
       <p:cxnSp>
         <p:nvCxnSpPr>
-          <p:cNvPr id="41" name=""/>
+          <p:cNvPr id="69" name=""/>
           <p:cNvCxnSpPr>
             <a:stCxn xmlns:a="http://schemas.openxmlformats.org/drawingml/2006/main" id="6" idx="3"/>
             <a:endCxn xmlns:a="http://schemas.openxmlformats.org/drawingml/2006/main" id="10" idx="1"/>
@@ -14991,7 +14981,7 @@
                 <a:ea typeface="Calibri"/>
                 <a:cs typeface="Calibri"/>
               </a:rPr>
-              <a:t>HARD CONSTRAINTS</a:t>
+              <a:t>NON-NEGOTIABLE</a:t>
             </a:r>
           </a:p>
         </p:txBody>
@@ -15026,7 +15016,7 @@
         </p:spPr>
         <p:txBody>
           <a:bodyPr xmlns:a="http://schemas.openxmlformats.org/drawingml/2006/main" wrap="square" lIns="0" tIns="0" rIns="0" bIns="0" anchor="ctr">
-            <a:normAutofit fontScale="86434"/>
+            <a:normAutofit fontScale="100000"/>
           </a:bodyPr>
           <a:lstStyle xmlns:a="http://schemas.openxmlformats.org/drawingml/2006/main"/>
           <a:p xmlns:a="http://schemas.openxmlformats.org/drawingml/2006/main">
@@ -15053,7 +15043,7 @@
                 <a:ea typeface="Calibri"/>
                 <a:cs typeface="Calibri"/>
               </a:rPr>
-              <a:t>table integrity · complete provenance · stable parent links</a:t>
+              <a:t>table integrity · provenance · stable IDs</a:t>
             </a:r>
           </a:p>
         </p:txBody>
@@ -15148,7 +15138,7 @@
                 <a:ea typeface="Calibri"/>
                 <a:cs typeface="Calibri"/>
               </a:rPr>
-              <a:t>OPTIMIZE WITH EVALUATION</a:t>
+              <a:t>MEASURE BEFORE ADDING</a:t>
             </a:r>
           </a:p>
         </p:txBody>
@@ -15210,7 +15200,7 @@
                 <a:ea typeface="Calibri"/>
                 <a:cs typeface="Calibri"/>
               </a:rPr>
-              <a:t>chunk size · context tokens · recall · cost</a:t>
+              <a:t>tokens · latency · recall · transformation risk</a:t>
             </a:r>
           </a:p>
         </p:txBody>
@@ -15245,7 +15235,7 @@
         </p:spPr>
         <p:txBody>
           <a:bodyPr xmlns:a="http://schemas.openxmlformats.org/drawingml/2006/main" wrap="square" lIns="0" tIns="0" rIns="0" bIns="0" anchor="ctr">
-            <a:normAutofit fontScale="100000"/>
+            <a:normAutofit fontScale="99269"/>
           </a:bodyPr>
           <a:lstStyle xmlns:a="http://schemas.openxmlformats.org/drawingml/2006/main"/>
           <a:p xmlns:a="http://schemas.openxmlformats.org/drawingml/2006/main">
@@ -15272,7 +15262,7 @@
                 <a:ea typeface="Calibri"/>
                 <a:cs typeface="Calibri"/>
               </a:rPr>
-              <a:t>LESSON 06</a:t>
+              <a:t>NEXT · LESSON 06</a:t>
             </a:r>
           </a:p>
         </p:txBody>
@@ -15307,7 +15297,7 @@
         </p:spPr>
         <p:txBody>
           <a:bodyPr xmlns:a="http://schemas.openxmlformats.org/drawingml/2006/main" wrap="square" lIns="0" tIns="0" rIns="0" bIns="0" anchor="ctr">
-            <a:normAutofit fontScale="99778"/>
+            <a:normAutofit fontScale="100000"/>
           </a:bodyPr>
           <a:lstStyle xmlns:a="http://schemas.openxmlformats.org/drawingml/2006/main"/>
           <a:p xmlns:a="http://schemas.openxmlformats.org/drawingml/2006/main">
@@ -15334,7 +15324,7 @@
                 <a:ea typeface="Calibri"/>
                 <a:cs typeface="Calibri"/>
               </a:rPr>
-              <a:t>Keep the chunks; improve representation and ranking with embeddings, filters, fusion and reranking.</a:t>
+              <a:t>Keep the chunks; improve candidate retrieval with embeddings, filters, fusion and reranking.</a:t>
             </a:r>
           </a:p>
         </p:txBody>

</xml_diff>